<commit_message>
Fix rupee symbol rendering on CloudConvert/LibreOffice and empty-bullet cleanup on removal edits
</commit_message>
<xml_diff>
--- a/templates/automation.pptx
+++ b/templates/automation.pptx
@@ -17244,7 +17244,31 @@
                 <a:cs typeface="Georgia"/>
                 <a:sym typeface="Georgia"/>
               </a:rPr>
-              <a:t>The ₹2,75,000 implementation remains complete and handover-ready. The Client receives the custom CRM, sales pipeline, dashboards, AI proposal generator, AI quotation generator, workflow automation, growth systems, training, configured integrations and the agreed outreach infrastructure for the initial included period, and can operate the system internally.</a:t>
+              <a:t>The </a:t>
+            </a:r>
+            <a:r>
+              <a:rPr lang="en-US" sz="3183">
+                <a:solidFill>
+                  <a:srgbClr val="33425C"/>
+                </a:solidFill>
+                <a:latin typeface="Playfair Display Bold"/>
+                <a:ea typeface="Playfair Display Bold"/>
+                <a:cs typeface="Playfair Display Bold"/>
+                <a:sym typeface="Playfair Display Bold"/>
+              </a:rPr>
+              <a:t>₹</a:t>
+            </a:r>
+            <a:r>
+              <a:rPr lang="en-US" sz="3183">
+                <a:solidFill>
+                  <a:srgbClr val="33425C"/>
+                </a:solidFill>
+                <a:latin typeface="Georgia"/>
+                <a:ea typeface="Georgia"/>
+                <a:cs typeface="Georgia"/>
+                <a:sym typeface="Georgia"/>
+              </a:rPr>
+              <a:t>2,75,000 implementation remains complete and handover-ready. The Client receives the custom CRM, sales pipeline, dashboards, AI proposal generator, AI quotation generator, workflow automation, growth systems, training, configured integrations and the agreed outreach infrastructure for the initial included period, and can operate the system internally.</a:t>
             </a:r>
           </a:p>
         </p:txBody>
@@ -17666,7 +17690,31 @@
                 <a:cs typeface="Georgia"/>
                 <a:sym typeface="Georgia"/>
               </a:rPr>
-              <a:t>IMPLEMENTATION FEE — ₹2,75,000 ONE-TIME</a:t>
+              <a:t>IMPLEMENTATION FEE — </a:t>
+            </a:r>
+            <a:r>
+              <a:rPr lang="en-US" sz="2017" spc="322">
+                <a:solidFill>
+                  <a:srgbClr val="8494AB"/>
+                </a:solidFill>
+                <a:latin typeface="Playfair Display Bold"/>
+                <a:ea typeface="Playfair Display Bold"/>
+                <a:cs typeface="Playfair Display Bold"/>
+                <a:sym typeface="Playfair Display Bold"/>
+              </a:rPr>
+              <a:t>₹</a:t>
+            </a:r>
+            <a:r>
+              <a:rPr lang="en-US" sz="2017" spc="322">
+                <a:solidFill>
+                  <a:srgbClr val="8494AB"/>
+                </a:solidFill>
+                <a:latin typeface="Georgia"/>
+                <a:ea typeface="Georgia"/>
+                <a:cs typeface="Georgia"/>
+                <a:sym typeface="Georgia"/>
+              </a:rPr>
+              <a:t>2,75,000 ONE-TIME</a:t>
             </a:r>
           </a:p>
         </p:txBody>
@@ -18430,12 +18478,24 @@
                   <a:solidFill>
                     <a:srgbClr val="33425C"/>
                   </a:solidFill>
+                  <a:latin typeface="Playfair Display Bold"/>
+                  <a:ea typeface="Playfair Display Bold"/>
+                  <a:cs typeface="Playfair Display Bold"/>
+                  <a:sym typeface="Playfair Display Bold"/>
+                </a:rPr>
+                <a:t>₹</a:t>
+              </a:r>
+              <a:r>
+                <a:rPr lang="en-US" sz="3183">
+                  <a:solidFill>
+                    <a:srgbClr val="33425C"/>
+                  </a:solidFill>
                   <a:latin typeface="Georgia"/>
                   <a:ea typeface="Georgia"/>
                   <a:cs typeface="Georgia"/>
                   <a:sym typeface="Georgia"/>
                 </a:rPr>
-                <a:t>₹1,65,000</a:t>
+                <a:t>1,65,000</a:t>
               </a:r>
             </a:p>
           </p:txBody>
@@ -18892,12 +18952,24 @@
                   <a:solidFill>
                     <a:srgbClr val="33425C"/>
                   </a:solidFill>
+                  <a:latin typeface="Playfair Display Bold"/>
+                  <a:ea typeface="Playfair Display Bold"/>
+                  <a:cs typeface="Playfair Display Bold"/>
+                  <a:sym typeface="Playfair Display Bold"/>
+                </a:rPr>
+                <a:t>₹</a:t>
+              </a:r>
+              <a:r>
+                <a:rPr lang="en-US" sz="3183">
+                  <a:solidFill>
+                    <a:srgbClr val="33425C"/>
+                  </a:solidFill>
                   <a:latin typeface="Georgia"/>
                   <a:ea typeface="Georgia"/>
                   <a:cs typeface="Georgia"/>
                   <a:sym typeface="Georgia"/>
                 </a:rPr>
-                <a:t>₹1,10,000</a:t>
+                <a:t>1,10,000</a:t>
               </a:r>
             </a:p>
           </p:txBody>
@@ -19354,12 +19426,24 @@
                   <a:solidFill>
                     <a:srgbClr val="1546E0"/>
                   </a:solidFill>
+                  <a:latin typeface="Playfair Display Bold"/>
+                  <a:ea typeface="Playfair Display Bold"/>
+                  <a:cs typeface="Playfair Display Bold"/>
+                  <a:sym typeface="Playfair Display Bold"/>
+                </a:rPr>
+                <a:t>₹</a:t>
+              </a:r>
+              <a:r>
+                <a:rPr lang="en-US" sz="3183">
+                  <a:solidFill>
+                    <a:srgbClr val="1546E0"/>
+                  </a:solidFill>
                   <a:latin typeface="Georgia"/>
                   <a:ea typeface="Georgia"/>
                   <a:cs typeface="Georgia"/>
                   <a:sym typeface="Georgia"/>
                 </a:rPr>
-                <a:t>₹2,75,000</a:t>
+                <a:t>2,75,000</a:t>
               </a:r>
             </a:p>
           </p:txBody>
@@ -19497,7 +19581,31 @@
                 <a:cs typeface="Georgia"/>
                 <a:sym typeface="Georgia"/>
               </a:rPr>
-              <a:t>CARE PLAN — ₹55,000 / MONTH</a:t>
+              <a:t>CARE PLAN — </a:t>
+            </a:r>
+            <a:r>
+              <a:rPr lang="en-US" sz="2017" spc="322">
+                <a:solidFill>
+                  <a:srgbClr val="8494AB"/>
+                </a:solidFill>
+                <a:latin typeface="Playfair Display Bold"/>
+                <a:ea typeface="Playfair Display Bold"/>
+                <a:cs typeface="Playfair Display Bold"/>
+                <a:sym typeface="Playfair Display Bold"/>
+              </a:rPr>
+              <a:t>₹</a:t>
+            </a:r>
+            <a:r>
+              <a:rPr lang="en-US" sz="2017" spc="322">
+                <a:solidFill>
+                  <a:srgbClr val="8494AB"/>
+                </a:solidFill>
+                <a:latin typeface="Georgia"/>
+                <a:ea typeface="Georgia"/>
+                <a:cs typeface="Georgia"/>
+                <a:sym typeface="Georgia"/>
+              </a:rPr>
+              <a:t>55,000 / MONTH</a:t>
             </a:r>
           </a:p>
         </p:txBody>
@@ -23213,12 +23321,24 @@
                   <a:solidFill>
                     <a:srgbClr val="1546E0"/>
                   </a:solidFill>
+                  <a:latin typeface="Playfair Display Bold"/>
+                  <a:ea typeface="Playfair Display Bold"/>
+                  <a:cs typeface="Playfair Display Bold"/>
+                  <a:sym typeface="Playfair Display Bold"/>
+                </a:rPr>
+                <a:t>₹</a:t>
+              </a:r>
+              <a:r>
+                <a:rPr lang="en-US" sz="3183">
+                  <a:solidFill>
+                    <a:srgbClr val="1546E0"/>
+                  </a:solidFill>
                   <a:latin typeface="Georgia"/>
                   <a:ea typeface="Georgia"/>
                   <a:cs typeface="Georgia"/>
                   <a:sym typeface="Georgia"/>
                 </a:rPr>
-                <a:t>₹2,75,000 one-time</a:t>
+                <a:t>2,75,000 one-time</a:t>
               </a:r>
             </a:p>
           </p:txBody>
@@ -23521,12 +23641,24 @@
                   <a:solidFill>
                     <a:srgbClr val="2E7D5B"/>
                   </a:solidFill>
+                  <a:latin typeface="Playfair Display Bold"/>
+                  <a:ea typeface="Playfair Display Bold"/>
+                  <a:cs typeface="Playfair Display Bold"/>
+                  <a:sym typeface="Playfair Display Bold"/>
+                </a:rPr>
+                <a:t>₹</a:t>
+              </a:r>
+              <a:r>
+                <a:rPr lang="en-US" sz="3183">
+                  <a:solidFill>
+                    <a:srgbClr val="2E7D5B"/>
+                  </a:solidFill>
                   <a:latin typeface="Georgia"/>
                   <a:ea typeface="Georgia"/>
                   <a:cs typeface="Georgia"/>
                   <a:sym typeface="Georgia"/>
                 </a:rPr>
-                <a:t>₹55,000 / month</a:t>
+                <a:t>55,000 / month</a:t>
               </a:r>
             </a:p>
           </p:txBody>
@@ -24475,94 +24607,142 @@
                 <a:solidFill>
                   <a:srgbClr val="33425C"/>
                 </a:solidFill>
+                <a:latin typeface="Playfair Display Bold"/>
+                <a:ea typeface="Playfair Display Bold"/>
+                <a:cs typeface="Playfair Display Bold"/>
+                <a:sym typeface="Playfair Display Bold"/>
+              </a:rPr>
+              <a:t>₹</a:t>
+            </a:r>
+            <a:r>
+              <a:rPr lang="en-US" sz="3078">
+                <a:solidFill>
+                  <a:srgbClr val="33425C"/>
+                </a:solidFill>
                 <a:latin typeface="Georgia"/>
                 <a:ea typeface="Georgia"/>
                 <a:cs typeface="Georgia"/>
                 <a:sym typeface="Georgia"/>
               </a:rPr>
-              <a:t>₹1,65,000 — 60% advance ₹1,10,000 — 40% on sign-off</a:t>
-            </a:r>
-          </a:p>
-        </p:txBody>
-      </p:sp>
-      <p:sp>
-        <p:nvSpPr>
-          <p:cNvPr name="TextBox 63" id="63"/>
-          <p:cNvSpPr txBox="true"/>
-          <p:nvPr/>
-        </p:nvSpPr>
-        <p:spPr>
-          <a:xfrm rot="0">
-            <a:off x="11534527" y="9166574"/>
-            <a:ext cx="8310162" cy="389982"/>
-          </a:xfrm>
-          <a:prstGeom prst="rect">
-            <a:avLst/>
-          </a:prstGeom>
-        </p:spPr>
-        <p:txBody>
-          <a:bodyPr anchor="t" rtlCol="false" tIns="0" lIns="0" bIns="0" rIns="0">
-            <a:spAutoFit/>
-          </a:bodyPr>
-          <a:lstStyle/>
-          <a:p>
-            <a:pPr algn="l">
-              <a:lnSpc>
-                <a:spcPts val="2421"/>
-              </a:lnSpc>
-            </a:pPr>
-            <a:r>
-              <a:rPr lang="en-US" sz="2017" spc="322">
-                <a:solidFill>
-                  <a:srgbClr val="8494AB"/>
+              <a:t>1,65,000 — 60% advance </a:t>
+            </a:r>
+            <a:r>
+              <a:rPr lang="en-US" sz="3078">
+                <a:solidFill>
+                  <a:srgbClr val="33425C"/>
+                </a:solidFill>
+                <a:latin typeface="Playfair Display Bold"/>
+                <a:ea typeface="Playfair Display Bold"/>
+                <a:cs typeface="Playfair Display Bold"/>
+                <a:sym typeface="Playfair Display Bold"/>
+              </a:rPr>
+              <a:t>₹</a:t>
+            </a:r>
+            <a:r>
+              <a:rPr lang="en-US" sz="3078">
+                <a:solidFill>
+                  <a:srgbClr val="33425C"/>
                 </a:solidFill>
                 <a:latin typeface="Georgia"/>
                 <a:ea typeface="Georgia"/>
                 <a:cs typeface="Georgia"/>
                 <a:sym typeface="Georgia"/>
               </a:rPr>
-              <a:t>OPTIONAL CARE PLAN</a:t>
-            </a:r>
-          </a:p>
-        </p:txBody>
-      </p:sp>
-      <p:sp>
-        <p:nvSpPr>
-          <p:cNvPr name="TextBox 64" id="64"/>
-          <p:cNvSpPr txBox="true"/>
-          <p:nvPr/>
-        </p:nvSpPr>
-        <p:spPr>
-          <a:xfrm rot="0">
-            <a:off x="11534527" y="9572301"/>
-            <a:ext cx="7778105" cy="1493653"/>
-          </a:xfrm>
-          <a:prstGeom prst="rect">
-            <a:avLst/>
-          </a:prstGeom>
-        </p:spPr>
-        <p:txBody>
-          <a:bodyPr anchor="t" rtlCol="false" tIns="0" lIns="0" bIns="0" rIns="0">
-            <a:spAutoFit/>
-          </a:bodyPr>
-          <a:lstStyle/>
-          <a:p>
-            <a:pPr algn="l">
-              <a:lnSpc>
-                <a:spcPts val="5059"/>
-              </a:lnSpc>
-            </a:pPr>
-            <a:r>
-              <a:rPr lang="en-US" sz="3078">
-                <a:solidFill>
-                  <a:srgbClr val="33425C"/>
+              <a:t>1,10,000 — 40% on sign-off</a:t>
+            </a:r>
+          </a:p>
+        </p:txBody>
+      </p:sp>
+      <p:sp>
+        <p:nvSpPr>
+          <p:cNvPr name="TextBox 63" id="63"/>
+          <p:cNvSpPr txBox="true"/>
+          <p:nvPr/>
+        </p:nvSpPr>
+        <p:spPr>
+          <a:xfrm rot="0">
+            <a:off x="11534527" y="9166574"/>
+            <a:ext cx="8310162" cy="389982"/>
+          </a:xfrm>
+          <a:prstGeom prst="rect">
+            <a:avLst/>
+          </a:prstGeom>
+        </p:spPr>
+        <p:txBody>
+          <a:bodyPr anchor="t" rtlCol="false" tIns="0" lIns="0" bIns="0" rIns="0">
+            <a:spAutoFit/>
+          </a:bodyPr>
+          <a:lstStyle/>
+          <a:p>
+            <a:pPr algn="l">
+              <a:lnSpc>
+                <a:spcPts val="2421"/>
+              </a:lnSpc>
+            </a:pPr>
+            <a:r>
+              <a:rPr lang="en-US" sz="2017" spc="322">
+                <a:solidFill>
+                  <a:srgbClr val="8494AB"/>
                 </a:solidFill>
                 <a:latin typeface="Georgia"/>
                 <a:ea typeface="Georgia"/>
                 <a:cs typeface="Georgia"/>
                 <a:sym typeface="Georgia"/>
               </a:rPr>
-              <a:t>₹55,000 / month Billed monthly in advance</a:t>
+              <a:t>OPTIONAL CARE PLAN</a:t>
+            </a:r>
+          </a:p>
+        </p:txBody>
+      </p:sp>
+      <p:sp>
+        <p:nvSpPr>
+          <p:cNvPr name="TextBox 64" id="64"/>
+          <p:cNvSpPr txBox="true"/>
+          <p:nvPr/>
+        </p:nvSpPr>
+        <p:spPr>
+          <a:xfrm rot="0">
+            <a:off x="11534527" y="9572301"/>
+            <a:ext cx="7778105" cy="1493653"/>
+          </a:xfrm>
+          <a:prstGeom prst="rect">
+            <a:avLst/>
+          </a:prstGeom>
+        </p:spPr>
+        <p:txBody>
+          <a:bodyPr anchor="t" rtlCol="false" tIns="0" lIns="0" bIns="0" rIns="0">
+            <a:spAutoFit/>
+          </a:bodyPr>
+          <a:lstStyle/>
+          <a:p>
+            <a:pPr algn="l">
+              <a:lnSpc>
+                <a:spcPts val="5059"/>
+              </a:lnSpc>
+            </a:pPr>
+            <a:r>
+              <a:rPr lang="en-US" sz="3078">
+                <a:solidFill>
+                  <a:srgbClr val="33425C"/>
+                </a:solidFill>
+                <a:latin typeface="Playfair Display Bold"/>
+                <a:ea typeface="Playfair Display Bold"/>
+                <a:cs typeface="Playfair Display Bold"/>
+                <a:sym typeface="Playfair Display Bold"/>
+              </a:rPr>
+              <a:t>₹</a:t>
+            </a:r>
+            <a:r>
+              <a:rPr lang="en-US" sz="3078">
+                <a:solidFill>
+                  <a:srgbClr val="33425C"/>
+                </a:solidFill>
+                <a:latin typeface="Georgia"/>
+                <a:ea typeface="Georgia"/>
+                <a:cs typeface="Georgia"/>
+                <a:sym typeface="Georgia"/>
+              </a:rPr>
+              <a:t>55,000 / month Billed monthly in advance</a:t>
             </a:r>
           </a:p>
         </p:txBody>

</xml_diff>